<commit_message>
Add lecture notes 2026.02.22.
</commit_message>
<xml_diff>
--- a/slide/CA3060-3-CallingConvention.pptx
+++ b/slide/CA3060-3-CallingConvention.pptx
@@ -161,226 +161,53 @@
 </p:presentation>
 </file>
 
+<file path=ppt/revisionInfo.xml><?xml version="1.0" encoding="utf-8"?>
+<p1510:revInfo xmlns:a="http://schemas.openxmlformats.org/drawingml/2006/main" xmlns:r="http://schemas.openxmlformats.org/officeDocument/2006/relationships" xmlns:p1510="http://schemas.microsoft.com/office/powerpoint/2015/10/main">
+  <p1510:revLst>
+    <p1510:client id="{9915B11C-5D81-44A0-80F5-19D750EDEFEA}" v="2" dt="2026-02-22T14:05:32.049"/>
+  </p1510:revLst>
+</p1510:revInfo>
+</file>
+
 <file path=ppt/changesInfos/changesInfo1.xml><?xml version="1.0" encoding="utf-8"?>
 <pc:chgInfo xmlns:a="http://schemas.openxmlformats.org/drawingml/2006/main" xmlns:r="http://schemas.openxmlformats.org/officeDocument/2006/relationships" xmlns:ac="http://schemas.microsoft.com/office/drawing/2013/main/command" xmlns:pc="http://schemas.microsoft.com/office/powerpoint/2013/main/command">
   <pc:docChgLst>
-    <pc:chgData name="Prof. Wang Fangxin (SSE)" userId="ce1f3ee1-525b-4f0b-8f12-bc5b2dd7d371" providerId="ADAL" clId="{072444D5-B6E1-794C-B782-80CEB355B39B}"/>
-    <pc:docChg chg="undo custSel addSld modSld">
-      <pc:chgData name="Prof. Wang Fangxin (SSE)" userId="ce1f3ee1-525b-4f0b-8f12-bc5b2dd7d371" providerId="ADAL" clId="{072444D5-B6E1-794C-B782-80CEB355B39B}" dt="2023-01-04T10:36:32.720" v="702" actId="20577"/>
+    <pc:chgData name="Chaoyi Sun (SDS,124090550)" userId="7336b744-5857-42bc-9fde-1c1347a32774" providerId="ADAL" clId="{3A35FEB6-D186-4DFE-8550-C935A8639321}"/>
+    <pc:docChg chg="undo custSel modSld">
+      <pc:chgData name="Chaoyi Sun (SDS,124090550)" userId="7336b744-5857-42bc-9fde-1c1347a32774" providerId="ADAL" clId="{3A35FEB6-D186-4DFE-8550-C935A8639321}" dt="2026-02-22T14:05:32.049" v="5" actId="478"/>
       <pc:docMkLst>
         <pc:docMk/>
       </pc:docMkLst>
-      <pc:sldChg chg="modSp mod">
-        <pc:chgData name="Prof. Wang Fangxin (SSE)" userId="ce1f3ee1-525b-4f0b-8f12-bc5b2dd7d371" providerId="ADAL" clId="{072444D5-B6E1-794C-B782-80CEB355B39B}" dt="2023-01-04T10:36:26.792" v="695" actId="20577"/>
+      <pc:sldChg chg="delSp modSp mod">
+        <pc:chgData name="Chaoyi Sun (SDS,124090550)" userId="7336b744-5857-42bc-9fde-1c1347a32774" providerId="ADAL" clId="{3A35FEB6-D186-4DFE-8550-C935A8639321}" dt="2026-02-22T14:05:32.049" v="5" actId="478"/>
         <pc:sldMkLst>
           <pc:docMk/>
-          <pc:sldMk cId="0" sldId="296"/>
+          <pc:sldMk cId="0" sldId="401"/>
         </pc:sldMkLst>
-        <pc:spChg chg="mod">
-          <ac:chgData name="Prof. Wang Fangxin (SSE)" userId="ce1f3ee1-525b-4f0b-8f12-bc5b2dd7d371" providerId="ADAL" clId="{072444D5-B6E1-794C-B782-80CEB355B39B}" dt="2023-01-04T10:36:06.733" v="685" actId="20577"/>
+        <pc:spChg chg="del mod">
+          <ac:chgData name="Chaoyi Sun (SDS,124090550)" userId="7336b744-5857-42bc-9fde-1c1347a32774" providerId="ADAL" clId="{3A35FEB6-D186-4DFE-8550-C935A8639321}" dt="2026-02-22T14:05:32.049" v="5" actId="478"/>
           <ac:spMkLst>
             <pc:docMk/>
-            <pc:sldMk cId="0" sldId="296"/>
-            <ac:spMk id="3" creationId="{00000000-0000-0000-0000-000000000000}"/>
+            <pc:sldMk cId="0" sldId="401"/>
+            <ac:spMk id="3075" creationId="{373909FB-C636-447F-9272-5642CFE0E444}"/>
           </ac:spMkLst>
         </pc:spChg>
-        <pc:spChg chg="mod">
-          <ac:chgData name="Prof. Wang Fangxin (SSE)" userId="ce1f3ee1-525b-4f0b-8f12-bc5b2dd7d371" providerId="ADAL" clId="{072444D5-B6E1-794C-B782-80CEB355B39B}" dt="2023-01-04T10:36:26.792" v="695" actId="20577"/>
-          <ac:spMkLst>
+        <pc:cxnChg chg="mod">
+          <ac:chgData name="Chaoyi Sun (SDS,124090550)" userId="7336b744-5857-42bc-9fde-1c1347a32774" providerId="ADAL" clId="{3A35FEB6-D186-4DFE-8550-C935A8639321}" dt="2026-02-22T14:05:22.829" v="3" actId="1076"/>
+          <ac:cxnSpMkLst>
             <pc:docMk/>
-            <pc:sldMk cId="0" sldId="296"/>
-            <ac:spMk id="6" creationId="{00000000-0000-0000-0000-000000000000}"/>
-          </ac:spMkLst>
-        </pc:spChg>
-      </pc:sldChg>
-      <pc:sldChg chg="modSp mod">
-        <pc:chgData name="Prof. Wang Fangxin (SSE)" userId="ce1f3ee1-525b-4f0b-8f12-bc5b2dd7d371" providerId="ADAL" clId="{072444D5-B6E1-794C-B782-80CEB355B39B}" dt="2023-01-04T10:27:49.456" v="356" actId="20577"/>
-        <pc:sldMkLst>
-          <pc:docMk/>
-          <pc:sldMk cId="0" sldId="299"/>
-        </pc:sldMkLst>
-        <pc:spChg chg="mod">
-          <ac:chgData name="Prof. Wang Fangxin (SSE)" userId="ce1f3ee1-525b-4f0b-8f12-bc5b2dd7d371" providerId="ADAL" clId="{072444D5-B6E1-794C-B782-80CEB355B39B}" dt="2023-01-04T10:27:49.456" v="356" actId="20577"/>
-          <ac:spMkLst>
+            <pc:sldMk cId="0" sldId="401"/>
+            <ac:cxnSpMk id="4" creationId="{1A10491C-6F0E-4759-B05E-A66729B80E11}"/>
+          </ac:cxnSpMkLst>
+        </pc:cxnChg>
+        <pc:cxnChg chg="mod">
+          <ac:chgData name="Chaoyi Sun (SDS,124090550)" userId="7336b744-5857-42bc-9fde-1c1347a32774" providerId="ADAL" clId="{3A35FEB6-D186-4DFE-8550-C935A8639321}" dt="2026-02-22T14:05:22.330" v="2" actId="1076"/>
+          <ac:cxnSpMkLst>
             <pc:docMk/>
-            <pc:sldMk cId="0" sldId="299"/>
-            <ac:spMk id="3" creationId="{00000000-0000-0000-0000-000000000000}"/>
-          </ac:spMkLst>
-        </pc:spChg>
-      </pc:sldChg>
-      <pc:sldChg chg="modSp mod">
-        <pc:chgData name="Prof. Wang Fangxin (SSE)" userId="ce1f3ee1-525b-4f0b-8f12-bc5b2dd7d371" providerId="ADAL" clId="{072444D5-B6E1-794C-B782-80CEB355B39B}" dt="2023-01-04T10:24:58.830" v="335" actId="20577"/>
-        <pc:sldMkLst>
-          <pc:docMk/>
-          <pc:sldMk cId="0" sldId="391"/>
-        </pc:sldMkLst>
-        <pc:spChg chg="mod">
-          <ac:chgData name="Prof. Wang Fangxin (SSE)" userId="ce1f3ee1-525b-4f0b-8f12-bc5b2dd7d371" providerId="ADAL" clId="{072444D5-B6E1-794C-B782-80CEB355B39B}" dt="2023-01-04T10:24:58.830" v="335" actId="20577"/>
-          <ac:spMkLst>
-            <pc:docMk/>
-            <pc:sldMk cId="0" sldId="391"/>
-            <ac:spMk id="6" creationId="{00000000-0000-0000-0000-000000000000}"/>
-          </ac:spMkLst>
-        </pc:spChg>
-      </pc:sldChg>
-      <pc:sldChg chg="modSp add mod">
-        <pc:chgData name="Prof. Wang Fangxin (SSE)" userId="ce1f3ee1-525b-4f0b-8f12-bc5b2dd7d371" providerId="ADAL" clId="{072444D5-B6E1-794C-B782-80CEB355B39B}" dt="2023-01-04T10:36:32.720" v="702" actId="20577"/>
-        <pc:sldMkLst>
-          <pc:docMk/>
-          <pc:sldMk cId="2341894575" sldId="447"/>
-        </pc:sldMkLst>
-        <pc:spChg chg="mod">
-          <ac:chgData name="Prof. Wang Fangxin (SSE)" userId="ce1f3ee1-525b-4f0b-8f12-bc5b2dd7d371" providerId="ADAL" clId="{072444D5-B6E1-794C-B782-80CEB355B39B}" dt="2023-01-04T10:32:31.287" v="384" actId="20577"/>
-          <ac:spMkLst>
-            <pc:docMk/>
-            <pc:sldMk cId="2341894575" sldId="447"/>
-            <ac:spMk id="3" creationId="{00000000-0000-0000-0000-000000000000}"/>
-          </ac:spMkLst>
-        </pc:spChg>
-        <pc:spChg chg="mod">
-          <ac:chgData name="Prof. Wang Fangxin (SSE)" userId="ce1f3ee1-525b-4f0b-8f12-bc5b2dd7d371" providerId="ADAL" clId="{072444D5-B6E1-794C-B782-80CEB355B39B}" dt="2023-01-04T10:36:32.720" v="702" actId="20577"/>
-          <ac:spMkLst>
-            <pc:docMk/>
-            <pc:sldMk cId="2341894575" sldId="447"/>
-            <ac:spMk id="6" creationId="{00000000-0000-0000-0000-000000000000}"/>
-          </ac:spMkLst>
-        </pc:spChg>
-      </pc:sldChg>
-    </pc:docChg>
-  </pc:docChgLst>
-  <pc:docChgLst>
-    <pc:chgData name="Prof. Wang Fangxin (SSE)" userId="ce1f3ee1-525b-4f0b-8f12-bc5b2dd7d371" providerId="ADAL" clId="{56731C7C-97E0-41C3-86F4-ADF8CE8A2053}"/>
-    <pc:docChg chg="undo custSel delSld modSld sldOrd">
-      <pc:chgData name="Prof. Wang Fangxin (SSE)" userId="ce1f3ee1-525b-4f0b-8f12-bc5b2dd7d371" providerId="ADAL" clId="{56731C7C-97E0-41C3-86F4-ADF8CE8A2053}" dt="2022-01-10T06:59:30.151" v="590" actId="2696"/>
-      <pc:docMkLst>
-        <pc:docMk/>
-      </pc:docMkLst>
-      <pc:sldChg chg="modSp">
-        <pc:chgData name="Prof. Wang Fangxin (SSE)" userId="ce1f3ee1-525b-4f0b-8f12-bc5b2dd7d371" providerId="ADAL" clId="{56731C7C-97E0-41C3-86F4-ADF8CE8A2053}" dt="2022-01-10T06:28:47.372" v="1" actId="27636"/>
-        <pc:sldMkLst>
-          <pc:docMk/>
-          <pc:sldMk cId="0" sldId="262"/>
-        </pc:sldMkLst>
-        <pc:spChg chg="mod">
-          <ac:chgData name="Prof. Wang Fangxin (SSE)" userId="ce1f3ee1-525b-4f0b-8f12-bc5b2dd7d371" providerId="ADAL" clId="{56731C7C-97E0-41C3-86F4-ADF8CE8A2053}" dt="2022-01-10T06:28:47.372" v="1" actId="27636"/>
-          <ac:spMkLst>
-            <pc:docMk/>
-            <pc:sldMk cId="0" sldId="262"/>
-            <ac:spMk id="3" creationId="{00000000-0000-0000-0000-000000000000}"/>
-          </ac:spMkLst>
-        </pc:spChg>
-      </pc:sldChg>
-      <pc:sldChg chg="del">
-        <pc:chgData name="Prof. Wang Fangxin (SSE)" userId="ce1f3ee1-525b-4f0b-8f12-bc5b2dd7d371" providerId="ADAL" clId="{56731C7C-97E0-41C3-86F4-ADF8CE8A2053}" dt="2022-01-10T06:59:30.151" v="590" actId="2696"/>
-        <pc:sldMkLst>
-          <pc:docMk/>
-          <pc:sldMk cId="0" sldId="272"/>
-        </pc:sldMkLst>
-      </pc:sldChg>
-      <pc:sldChg chg="addSp modSp">
-        <pc:chgData name="Prof. Wang Fangxin (SSE)" userId="ce1f3ee1-525b-4f0b-8f12-bc5b2dd7d371" providerId="ADAL" clId="{56731C7C-97E0-41C3-86F4-ADF8CE8A2053}" dt="2022-01-10T06:30:29.070" v="33" actId="1076"/>
-        <pc:sldMkLst>
-          <pc:docMk/>
-          <pc:sldMk cId="0" sldId="295"/>
-        </pc:sldMkLst>
-        <pc:spChg chg="add mod">
-          <ac:chgData name="Prof. Wang Fangxin (SSE)" userId="ce1f3ee1-525b-4f0b-8f12-bc5b2dd7d371" providerId="ADAL" clId="{56731C7C-97E0-41C3-86F4-ADF8CE8A2053}" dt="2022-01-10T06:30:29.070" v="33" actId="1076"/>
-          <ac:spMkLst>
-            <pc:docMk/>
-            <pc:sldMk cId="0" sldId="295"/>
-            <ac:spMk id="4" creationId="{5E4FC43E-652B-47EE-A940-42294AB0E172}"/>
-          </ac:spMkLst>
-        </pc:spChg>
-      </pc:sldChg>
-      <pc:sldChg chg="modSp">
-        <pc:chgData name="Prof. Wang Fangxin (SSE)" userId="ce1f3ee1-525b-4f0b-8f12-bc5b2dd7d371" providerId="ADAL" clId="{56731C7C-97E0-41C3-86F4-ADF8CE8A2053}" dt="2022-01-10T06:51:11.053" v="586" actId="404"/>
-        <pc:sldMkLst>
-          <pc:docMk/>
-          <pc:sldMk cId="0" sldId="296"/>
-        </pc:sldMkLst>
-        <pc:spChg chg="mod">
-          <ac:chgData name="Prof. Wang Fangxin (SSE)" userId="ce1f3ee1-525b-4f0b-8f12-bc5b2dd7d371" providerId="ADAL" clId="{56731C7C-97E0-41C3-86F4-ADF8CE8A2053}" dt="2022-01-10T06:51:11.053" v="586" actId="404"/>
-          <ac:spMkLst>
-            <pc:docMk/>
-            <pc:sldMk cId="0" sldId="296"/>
-            <ac:spMk id="3" creationId="{00000000-0000-0000-0000-000000000000}"/>
-          </ac:spMkLst>
-        </pc:spChg>
-      </pc:sldChg>
-      <pc:sldChg chg="modSp">
-        <pc:chgData name="Prof. Wang Fangxin (SSE)" userId="ce1f3ee1-525b-4f0b-8f12-bc5b2dd7d371" providerId="ADAL" clId="{56731C7C-97E0-41C3-86F4-ADF8CE8A2053}" dt="2022-01-10T06:44:19.141" v="478" actId="207"/>
-        <pc:sldMkLst>
-          <pc:docMk/>
-          <pc:sldMk cId="0" sldId="299"/>
-        </pc:sldMkLst>
-        <pc:spChg chg="mod">
-          <ac:chgData name="Prof. Wang Fangxin (SSE)" userId="ce1f3ee1-525b-4f0b-8f12-bc5b2dd7d371" providerId="ADAL" clId="{56731C7C-97E0-41C3-86F4-ADF8CE8A2053}" dt="2022-01-10T06:44:19.141" v="478" actId="207"/>
-          <ac:spMkLst>
-            <pc:docMk/>
-            <pc:sldMk cId="0" sldId="299"/>
-            <ac:spMk id="3" creationId="{00000000-0000-0000-0000-000000000000}"/>
-          </ac:spMkLst>
-        </pc:spChg>
-      </pc:sldChg>
-      <pc:sldChg chg="modSp ord">
-        <pc:chgData name="Prof. Wang Fangxin (SSE)" userId="ce1f3ee1-525b-4f0b-8f12-bc5b2dd7d371" providerId="ADAL" clId="{56731C7C-97E0-41C3-86F4-ADF8CE8A2053}" dt="2022-01-10T06:48:53.068" v="570" actId="207"/>
-        <pc:sldMkLst>
-          <pc:docMk/>
-          <pc:sldMk cId="0" sldId="301"/>
-        </pc:sldMkLst>
-        <pc:spChg chg="mod">
-          <ac:chgData name="Prof. Wang Fangxin (SSE)" userId="ce1f3ee1-525b-4f0b-8f12-bc5b2dd7d371" providerId="ADAL" clId="{56731C7C-97E0-41C3-86F4-ADF8CE8A2053}" dt="2022-01-10T06:48:53.068" v="570" actId="207"/>
-          <ac:spMkLst>
-            <pc:docMk/>
-            <pc:sldMk cId="0" sldId="301"/>
-            <ac:spMk id="3" creationId="{00000000-0000-0000-0000-000000000000}"/>
-          </ac:spMkLst>
-        </pc:spChg>
-      </pc:sldChg>
-      <pc:sldChg chg="modSp">
-        <pc:chgData name="Prof. Wang Fangxin (SSE)" userId="ce1f3ee1-525b-4f0b-8f12-bc5b2dd7d371" providerId="ADAL" clId="{56731C7C-97E0-41C3-86F4-ADF8CE8A2053}" dt="2022-01-10T06:51:17.850" v="588" actId="404"/>
-        <pc:sldMkLst>
-          <pc:docMk/>
-          <pc:sldMk cId="0" sldId="391"/>
-        </pc:sldMkLst>
-        <pc:spChg chg="mod">
-          <ac:chgData name="Prof. Wang Fangxin (SSE)" userId="ce1f3ee1-525b-4f0b-8f12-bc5b2dd7d371" providerId="ADAL" clId="{56731C7C-97E0-41C3-86F4-ADF8CE8A2053}" dt="2022-01-10T06:51:17.850" v="588" actId="404"/>
-          <ac:spMkLst>
-            <pc:docMk/>
-            <pc:sldMk cId="0" sldId="391"/>
-            <ac:spMk id="6" creationId="{00000000-0000-0000-0000-000000000000}"/>
-          </ac:spMkLst>
-        </pc:spChg>
-      </pc:sldChg>
-      <pc:sldChg chg="modSp del">
-        <pc:chgData name="Prof. Wang Fangxin (SSE)" userId="ce1f3ee1-525b-4f0b-8f12-bc5b2dd7d371" providerId="ADAL" clId="{56731C7C-97E0-41C3-86F4-ADF8CE8A2053}" dt="2022-01-10T06:51:27.305" v="589" actId="2696"/>
-        <pc:sldMkLst>
-          <pc:docMk/>
-          <pc:sldMk cId="0" sldId="392"/>
-        </pc:sldMkLst>
-        <pc:spChg chg="mod">
-          <ac:chgData name="Prof. Wang Fangxin (SSE)" userId="ce1f3ee1-525b-4f0b-8f12-bc5b2dd7d371" providerId="ADAL" clId="{56731C7C-97E0-41C3-86F4-ADF8CE8A2053}" dt="2022-01-10T06:41:58.169" v="400" actId="20577"/>
-          <ac:spMkLst>
-            <pc:docMk/>
-            <pc:sldMk cId="0" sldId="392"/>
-            <ac:spMk id="6" creationId="{00000000-0000-0000-0000-000000000000}"/>
-          </ac:spMkLst>
-        </pc:spChg>
-      </pc:sldChg>
-      <pc:sldChg chg="modSp">
-        <pc:chgData name="Prof. Wang Fangxin (SSE)" userId="ce1f3ee1-525b-4f0b-8f12-bc5b2dd7d371" providerId="ADAL" clId="{56731C7C-97E0-41C3-86F4-ADF8CE8A2053}" dt="2022-01-10T06:45:25" v="501" actId="20577"/>
-        <pc:sldMkLst>
-          <pc:docMk/>
-          <pc:sldMk cId="0" sldId="445"/>
-        </pc:sldMkLst>
-        <pc:spChg chg="mod">
-          <ac:chgData name="Prof. Wang Fangxin (SSE)" userId="ce1f3ee1-525b-4f0b-8f12-bc5b2dd7d371" providerId="ADAL" clId="{56731C7C-97E0-41C3-86F4-ADF8CE8A2053}" dt="2022-01-10T06:45:25" v="501" actId="20577"/>
-          <ac:spMkLst>
-            <pc:docMk/>
-            <pc:sldMk cId="0" sldId="445"/>
-            <ac:spMk id="3" creationId="{00000000-0000-0000-0000-000000000000}"/>
-          </ac:spMkLst>
-        </pc:spChg>
+            <pc:sldMk cId="0" sldId="401"/>
+            <ac:cxnSpMk id="8" creationId="{357E6135-011E-414F-9470-59A461A609E3}"/>
+          </ac:cxnSpMkLst>
+        </pc:cxnChg>
       </pc:sldChg>
     </pc:docChg>
   </pc:docChgLst>
@@ -469,7 +296,7 @@
           <a:p>
             <a:fld id="{45BDCE37-E9BE-4280-8D68-34E43D66CEDB}" type="datetimeFigureOut">
               <a:rPr lang="zh-TW" altLang="en-US" smtClean="0"/>
-              <a:t>2026/1/24</a:t>
+              <a:t>2026/2/22</a:t>
             </a:fld>
             <a:endParaRPr lang="zh-TW" altLang="en-US"/>
           </a:p>
@@ -634,7 +461,7 @@
           <a:p>
             <a:fld id="{FBFBA883-381C-409E-9635-BB54B21745E4}" type="datetimeFigureOut">
               <a:rPr lang="zh-TW" altLang="en-US" smtClean="0"/>
-              <a:t>2026/1/24</a:t>
+              <a:t>2026/2/22</a:t>
             </a:fld>
             <a:endParaRPr lang="zh-TW" altLang="en-US"/>
           </a:p>
@@ -23275,13 +23102,194 @@
               <a:buNone/>
             </a:pPr>
             <a:r>
-              <a:rPr lang="en-US" altLang="zh-TW" sz="2100" b="1">
+              <a:rPr lang="en-US" altLang="zh-TW" sz="2100" b="1" dirty="0">
                 <a:solidFill>
                   <a:srgbClr val="2929FF"/>
                 </a:solidFill>
                 <a:ea typeface="新細明體" panose="02020500000000000000" pitchFamily="18" charset="-120"/>
               </a:rPr>
               <a:t>Function A ()</a:t>
+            </a:r>
+          </a:p>
+          <a:p>
+            <a:pPr>
+              <a:spcBef>
+                <a:spcPct val="0"/>
+              </a:spcBef>
+              <a:buClrTx/>
+              <a:buSzTx/>
+              <a:buFontTx/>
+              <a:buNone/>
+            </a:pPr>
+            <a:r>
+              <a:rPr lang="en-US" altLang="zh-TW" sz="2100" b="1" dirty="0">
+                <a:solidFill>
+                  <a:srgbClr val="2929FF"/>
+                </a:solidFill>
+                <a:ea typeface="新細明體" panose="02020500000000000000" pitchFamily="18" charset="-120"/>
+              </a:rPr>
+              <a:t>…</a:t>
+            </a:r>
+          </a:p>
+          <a:p>
+            <a:pPr>
+              <a:spcBef>
+                <a:spcPct val="0"/>
+              </a:spcBef>
+              <a:buClrTx/>
+              <a:buSzTx/>
+              <a:buFontTx/>
+              <a:buNone/>
+            </a:pPr>
+            <a:r>
+              <a:rPr lang="en-US" altLang="zh-TW" sz="2100" b="1" dirty="0" err="1">
+                <a:solidFill>
+                  <a:srgbClr val="2929FF"/>
+                </a:solidFill>
+                <a:ea typeface="新細明體" panose="02020500000000000000" pitchFamily="18" charset="-120"/>
+              </a:rPr>
+              <a:t>lw</a:t>
+            </a:r>
+            <a:r>
+              <a:rPr lang="en-US" altLang="zh-TW" sz="2100" b="1" dirty="0">
+                <a:solidFill>
+                  <a:srgbClr val="2929FF"/>
+                </a:solidFill>
+                <a:ea typeface="新細明體" panose="02020500000000000000" pitchFamily="18" charset="-120"/>
+              </a:rPr>
+              <a:t> $8 -4($</a:t>
+            </a:r>
+            <a:r>
+              <a:rPr lang="en-US" altLang="zh-TW" sz="2100" b="1" dirty="0" err="1">
+                <a:solidFill>
+                  <a:srgbClr val="2929FF"/>
+                </a:solidFill>
+                <a:ea typeface="新細明體" panose="02020500000000000000" pitchFamily="18" charset="-120"/>
+              </a:rPr>
+              <a:t>fp</a:t>
+            </a:r>
+            <a:r>
+              <a:rPr lang="en-US" altLang="zh-TW" sz="2100" b="1" dirty="0">
+                <a:solidFill>
+                  <a:srgbClr val="2929FF"/>
+                </a:solidFill>
+                <a:ea typeface="新細明體" panose="02020500000000000000" pitchFamily="18" charset="-120"/>
+              </a:rPr>
+              <a:t>)</a:t>
+            </a:r>
+          </a:p>
+          <a:p>
+            <a:pPr>
+              <a:spcBef>
+                <a:spcPct val="0"/>
+              </a:spcBef>
+              <a:buClrTx/>
+              <a:buSzTx/>
+              <a:buFontTx/>
+              <a:buNone/>
+            </a:pPr>
+            <a:r>
+              <a:rPr lang="en-US" altLang="zh-TW" sz="2100" b="1" dirty="0" err="1">
+                <a:solidFill>
+                  <a:srgbClr val="2929FF"/>
+                </a:solidFill>
+                <a:ea typeface="新細明體" panose="02020500000000000000" pitchFamily="18" charset="-120"/>
+              </a:rPr>
+              <a:t>lw</a:t>
+            </a:r>
+            <a:r>
+              <a:rPr lang="en-US" altLang="zh-TW" sz="2100" b="1" dirty="0">
+                <a:solidFill>
+                  <a:srgbClr val="2929FF"/>
+                </a:solidFill>
+                <a:ea typeface="新細明體" panose="02020500000000000000" pitchFamily="18" charset="-120"/>
+              </a:rPr>
+              <a:t> $9 -8($</a:t>
+            </a:r>
+            <a:r>
+              <a:rPr lang="en-US" altLang="zh-TW" sz="2100" b="1" dirty="0" err="1">
+                <a:solidFill>
+                  <a:srgbClr val="2929FF"/>
+                </a:solidFill>
+                <a:ea typeface="新細明體" panose="02020500000000000000" pitchFamily="18" charset="-120"/>
+              </a:rPr>
+              <a:t>fp</a:t>
+            </a:r>
+            <a:r>
+              <a:rPr lang="en-US" altLang="zh-TW" sz="2100" b="1" dirty="0">
+                <a:solidFill>
+                  <a:srgbClr val="2929FF"/>
+                </a:solidFill>
+                <a:ea typeface="新細明體" panose="02020500000000000000" pitchFamily="18" charset="-120"/>
+              </a:rPr>
+              <a:t>)</a:t>
+            </a:r>
+          </a:p>
+          <a:p>
+            <a:pPr>
+              <a:spcBef>
+                <a:spcPct val="0"/>
+              </a:spcBef>
+              <a:buClrTx/>
+              <a:buSzTx/>
+              <a:buFontTx/>
+              <a:buNone/>
+            </a:pPr>
+            <a:r>
+              <a:rPr lang="en-US" altLang="zh-TW" sz="2100" b="1" dirty="0">
+                <a:solidFill>
+                  <a:srgbClr val="2929FF"/>
+                </a:solidFill>
+                <a:ea typeface="新細明體" panose="02020500000000000000" pitchFamily="18" charset="-120"/>
+              </a:rPr>
+              <a:t>add $10, $8,$9</a:t>
+            </a:r>
+          </a:p>
+          <a:p>
+            <a:pPr>
+              <a:spcBef>
+                <a:spcPct val="0"/>
+              </a:spcBef>
+              <a:buClrTx/>
+              <a:buSzTx/>
+              <a:buFontTx/>
+              <a:buNone/>
+            </a:pPr>
+            <a:r>
+              <a:rPr lang="en-US" altLang="zh-TW" sz="2100" b="1" dirty="0" err="1">
+                <a:solidFill>
+                  <a:srgbClr val="2929FF"/>
+                </a:solidFill>
+                <a:ea typeface="新細明體" panose="02020500000000000000" pitchFamily="18" charset="-120"/>
+              </a:rPr>
+              <a:t>sw</a:t>
+            </a:r>
+            <a:r>
+              <a:rPr lang="en-US" altLang="zh-TW" sz="2100" b="1" dirty="0">
+                <a:solidFill>
+                  <a:srgbClr val="2929FF"/>
+                </a:solidFill>
+                <a:ea typeface="新細明體" panose="02020500000000000000" pitchFamily="18" charset="-120"/>
+              </a:rPr>
+              <a:t> $10, -12($</a:t>
+            </a:r>
+            <a:r>
+              <a:rPr lang="en-US" altLang="zh-TW" sz="2100" b="1" dirty="0" err="1">
+                <a:solidFill>
+                  <a:srgbClr val="2929FF"/>
+                </a:solidFill>
+                <a:ea typeface="新細明體" panose="02020500000000000000" pitchFamily="18" charset="-120"/>
+              </a:rPr>
+              <a:t>fp</a:t>
+            </a:r>
+            <a:r>
+              <a:rPr lang="en-US" altLang="zh-TW" sz="2100" b="1" dirty="0">
+                <a:solidFill>
+                  <a:srgbClr val="2929FF"/>
+                </a:solidFill>
+                <a:ea typeface="新細明體" panose="02020500000000000000" pitchFamily="18" charset="-120"/>
+              </a:rPr>
+              <a:t>)</a:t>
             </a:r>
           </a:p>
           <a:p>
@@ -23301,7 +23309,7 @@
                 </a:solidFill>
                 <a:ea typeface="新細明體" panose="02020500000000000000" pitchFamily="18" charset="-120"/>
               </a:rPr>
-              <a:t>…</a:t>
+              <a:t>$v0 =  B(1,2,3); /* function call */</a:t>
             </a:r>
           </a:p>
           <a:p>
@@ -23315,13 +23323,13 @@
               <a:buNone/>
             </a:pPr>
             <a:r>
-              <a:rPr lang="en-US" altLang="zh-TW" sz="2100" b="1">
+              <a:rPr lang="en-US" altLang="zh-TW" sz="2100" b="1" dirty="0">
                 <a:solidFill>
                   <a:srgbClr val="2929FF"/>
                 </a:solidFill>
                 <a:ea typeface="新細明體" panose="02020500000000000000" pitchFamily="18" charset="-120"/>
               </a:rPr>
-              <a:t>lw $8 -4($fp)</a:t>
+              <a:t>add $v0, $v0, $v0</a:t>
             </a:r>
           </a:p>
           <a:p>
@@ -23335,107 +23343,7 @@
               <a:buNone/>
             </a:pPr>
             <a:r>
-              <a:rPr lang="en-US" altLang="zh-TW" sz="2100" b="1">
-                <a:solidFill>
-                  <a:srgbClr val="2929FF"/>
-                </a:solidFill>
-                <a:ea typeface="新細明體" panose="02020500000000000000" pitchFamily="18" charset="-120"/>
-              </a:rPr>
-              <a:t>lw $9 -8($fp)</a:t>
-            </a:r>
-          </a:p>
-          <a:p>
-            <a:pPr>
-              <a:spcBef>
-                <a:spcPct val="0"/>
-              </a:spcBef>
-              <a:buClrTx/>
-              <a:buSzTx/>
-              <a:buFontTx/>
-              <a:buNone/>
-            </a:pPr>
-            <a:r>
-              <a:rPr lang="en-US" altLang="zh-TW" sz="2100" b="1">
-                <a:solidFill>
-                  <a:srgbClr val="2929FF"/>
-                </a:solidFill>
-                <a:ea typeface="新細明體" panose="02020500000000000000" pitchFamily="18" charset="-120"/>
-              </a:rPr>
-              <a:t>add $10, $8,$9</a:t>
-            </a:r>
-          </a:p>
-          <a:p>
-            <a:pPr>
-              <a:spcBef>
-                <a:spcPct val="0"/>
-              </a:spcBef>
-              <a:buClrTx/>
-              <a:buSzTx/>
-              <a:buFontTx/>
-              <a:buNone/>
-            </a:pPr>
-            <a:r>
-              <a:rPr lang="en-US" altLang="zh-TW" sz="2100" b="1">
-                <a:solidFill>
-                  <a:srgbClr val="2929FF"/>
-                </a:solidFill>
-                <a:ea typeface="新細明體" panose="02020500000000000000" pitchFamily="18" charset="-120"/>
-              </a:rPr>
-              <a:t>sw $10, -12($fp)</a:t>
-            </a:r>
-          </a:p>
-          <a:p>
-            <a:pPr>
-              <a:spcBef>
-                <a:spcPct val="0"/>
-              </a:spcBef>
-              <a:buClrTx/>
-              <a:buSzTx/>
-              <a:buFontTx/>
-              <a:buNone/>
-            </a:pPr>
-            <a:r>
-              <a:rPr lang="en-US" altLang="zh-TW" sz="2100" b="1">
-                <a:solidFill>
-                  <a:srgbClr val="2929FF"/>
-                </a:solidFill>
-                <a:ea typeface="新細明體" panose="02020500000000000000" pitchFamily="18" charset="-120"/>
-              </a:rPr>
-              <a:t>$v0 =  B(1,2,3); /* function call */</a:t>
-            </a:r>
-          </a:p>
-          <a:p>
-            <a:pPr>
-              <a:spcBef>
-                <a:spcPct val="0"/>
-              </a:spcBef>
-              <a:buClrTx/>
-              <a:buSzTx/>
-              <a:buFontTx/>
-              <a:buNone/>
-            </a:pPr>
-            <a:r>
-              <a:rPr lang="en-US" altLang="zh-TW" sz="2100" b="1">
-                <a:solidFill>
-                  <a:srgbClr val="2929FF"/>
-                </a:solidFill>
-                <a:ea typeface="新細明體" panose="02020500000000000000" pitchFamily="18" charset="-120"/>
-              </a:rPr>
-              <a:t>add $v0, $v0, $v0</a:t>
-            </a:r>
-          </a:p>
-          <a:p>
-            <a:pPr>
-              <a:spcBef>
-                <a:spcPct val="0"/>
-              </a:spcBef>
-              <a:buClrTx/>
-              <a:buSzTx/>
-              <a:buFontTx/>
-              <a:buNone/>
-            </a:pPr>
-            <a:r>
-              <a:rPr lang="en-US" altLang="zh-TW" sz="2100" b="1">
+              <a:rPr lang="en-US" altLang="zh-TW" sz="2100" b="1" dirty="0">
                 <a:solidFill>
                   <a:srgbClr val="2929FF"/>
                 </a:solidFill>
@@ -23443,7 +23351,7 @@
               </a:rPr>
               <a:t>return</a:t>
             </a:r>
-            <a:endParaRPr lang="zh-TW" altLang="en-US" sz="2100" b="1">
+            <a:endParaRPr lang="zh-TW" altLang="en-US" sz="2100" b="1" dirty="0">
               <a:solidFill>
                 <a:srgbClr val="2929FF"/>
               </a:solidFill>
@@ -40243,208 +40151,6 @@
           <a:chExt cx="0" cy="0"/>
         </a:xfrm>
       </p:grpSpPr>
-      <p:sp>
-        <p:nvSpPr>
-          <p:cNvPr id="3075" name="Footer Placeholder 4">
-            <a:extLst>
-              <a:ext uri="{FF2B5EF4-FFF2-40B4-BE49-F238E27FC236}">
-                <a16:creationId xmlns:a16="http://schemas.microsoft.com/office/drawing/2014/main" id="{373909FB-C636-447F-9272-5642CFE0E444}"/>
-              </a:ext>
-            </a:extLst>
-          </p:cNvPr>
-          <p:cNvSpPr>
-            <a:spLocks noGrp="1"/>
-          </p:cNvSpPr>
-          <p:nvPr>
-            <p:ph type="ftr" sz="quarter" idx="4294967295"/>
-          </p:nvPr>
-        </p:nvSpPr>
-        <p:spPr bwMode="auto">
-          <a:xfrm>
-            <a:off x="1676400" y="6477000"/>
-            <a:ext cx="6172200" cy="304800"/>
-          </a:xfrm>
-          <a:prstGeom prst="rect">
-            <a:avLst/>
-          </a:prstGeom>
-          <a:noFill/>
-          <a:ln w="9525">
-            <a:noFill/>
-            <a:miter lim="800000"/>
-            <a:headEnd/>
-            <a:tailEnd/>
-          </a:ln>
-          <a:effectLst/>
-          <a:extLst>
-            <a:ext uri="{909E8E84-426E-40DD-AFC4-6F175D3DCCD1}">
-              <a14:hiddenFill xmlns:a14="http://schemas.microsoft.com/office/drawing/2010/main">
-                <a:solidFill>
-                  <a:srgbClr val="FFFFFF"/>
-                </a:solidFill>
-              </a14:hiddenFill>
-            </a:ext>
-            <a:ext uri="{91240B29-F687-4F45-9708-019B960494DF}">
-              <a14:hiddenLine xmlns:a14="http://schemas.microsoft.com/office/drawing/2010/main" w="9525">
-                <a:solidFill>
-                  <a:srgbClr val="000000"/>
-                </a:solidFill>
-                <a:miter lim="800000"/>
-                <a:headEnd/>
-                <a:tailEnd/>
-              </a14:hiddenLine>
-            </a:ext>
-          </a:extLst>
-        </p:spPr>
-        <p:txBody>
-          <a:bodyPr vert="horz" wrap="square" lIns="91440" tIns="45720" rIns="91440" bIns="45720" numCol="1" anchor="b" anchorCtr="0" compatLnSpc="1">
-            <a:prstTxWarp prst="textNoShape">
-              <a:avLst/>
-            </a:prstTxWarp>
-          </a:bodyPr>
-          <a:lstStyle>
-            <a:defPPr>
-              <a:defRPr lang="en-US"/>
-            </a:defPPr>
-            <a:lvl1pPr algn="ctr" rtl="0" eaLnBrk="1" fontAlgn="base" hangingPunct="1">
-              <a:spcBef>
-                <a:spcPct val="0"/>
-              </a:spcBef>
-              <a:spcAft>
-                <a:spcPct val="0"/>
-              </a:spcAft>
-              <a:defRPr sz="1400" kern="1200">
-                <a:solidFill>
-                  <a:schemeClr val="tx1"/>
-                </a:solidFill>
-                <a:effectLst>
-                  <a:outerShdw blurRad="38100" dist="38100" dir="2700000" algn="tl">
-                    <a:srgbClr val="000000"/>
-                  </a:outerShdw>
-                </a:effectLst>
-                <a:latin typeface="Arial" charset="0"/>
-                <a:ea typeface="新細明體" pitchFamily="18" charset="-120"/>
-                <a:cs typeface="+mn-cs"/>
-              </a:defRPr>
-            </a:lvl1pPr>
-            <a:lvl2pPr marL="457200" algn="l" rtl="0" eaLnBrk="0" fontAlgn="base" hangingPunct="0">
-              <a:spcBef>
-                <a:spcPct val="0"/>
-              </a:spcBef>
-              <a:spcAft>
-                <a:spcPct val="0"/>
-              </a:spcAft>
-              <a:defRPr kern="1200">
-                <a:solidFill>
-                  <a:schemeClr val="tx1"/>
-                </a:solidFill>
-                <a:latin typeface="Arial" panose="020B0604020202020204" pitchFamily="34" charset="0"/>
-                <a:ea typeface="+mn-ea"/>
-                <a:cs typeface="+mn-cs"/>
-              </a:defRPr>
-            </a:lvl2pPr>
-            <a:lvl3pPr marL="914400" algn="l" rtl="0" eaLnBrk="0" fontAlgn="base" hangingPunct="0">
-              <a:spcBef>
-                <a:spcPct val="0"/>
-              </a:spcBef>
-              <a:spcAft>
-                <a:spcPct val="0"/>
-              </a:spcAft>
-              <a:defRPr kern="1200">
-                <a:solidFill>
-                  <a:schemeClr val="tx1"/>
-                </a:solidFill>
-                <a:latin typeface="Arial" panose="020B0604020202020204" pitchFamily="34" charset="0"/>
-                <a:ea typeface="+mn-ea"/>
-                <a:cs typeface="+mn-cs"/>
-              </a:defRPr>
-            </a:lvl3pPr>
-            <a:lvl4pPr marL="1371600" algn="l" rtl="0" eaLnBrk="0" fontAlgn="base" hangingPunct="0">
-              <a:spcBef>
-                <a:spcPct val="0"/>
-              </a:spcBef>
-              <a:spcAft>
-                <a:spcPct val="0"/>
-              </a:spcAft>
-              <a:defRPr kern="1200">
-                <a:solidFill>
-                  <a:schemeClr val="tx1"/>
-                </a:solidFill>
-                <a:latin typeface="Arial" panose="020B0604020202020204" pitchFamily="34" charset="0"/>
-                <a:ea typeface="+mn-ea"/>
-                <a:cs typeface="+mn-cs"/>
-              </a:defRPr>
-            </a:lvl4pPr>
-            <a:lvl5pPr marL="1828800" algn="l" rtl="0" eaLnBrk="0" fontAlgn="base" hangingPunct="0">
-              <a:spcBef>
-                <a:spcPct val="0"/>
-              </a:spcBef>
-              <a:spcAft>
-                <a:spcPct val="0"/>
-              </a:spcAft>
-              <a:defRPr kern="1200">
-                <a:solidFill>
-                  <a:schemeClr val="tx1"/>
-                </a:solidFill>
-                <a:latin typeface="Arial" panose="020B0604020202020204" pitchFamily="34" charset="0"/>
-                <a:ea typeface="+mn-ea"/>
-                <a:cs typeface="+mn-cs"/>
-              </a:defRPr>
-            </a:lvl5pPr>
-            <a:lvl6pPr marL="2286000" algn="l" defTabSz="914400" rtl="0" eaLnBrk="1" latinLnBrk="0" hangingPunct="1">
-              <a:defRPr kern="1200">
-                <a:solidFill>
-                  <a:schemeClr val="tx1"/>
-                </a:solidFill>
-                <a:latin typeface="Arial" panose="020B0604020202020204" pitchFamily="34" charset="0"/>
-                <a:ea typeface="+mn-ea"/>
-                <a:cs typeface="+mn-cs"/>
-              </a:defRPr>
-            </a:lvl6pPr>
-            <a:lvl7pPr marL="2743200" algn="l" defTabSz="914400" rtl="0" eaLnBrk="1" latinLnBrk="0" hangingPunct="1">
-              <a:defRPr kern="1200">
-                <a:solidFill>
-                  <a:schemeClr val="tx1"/>
-                </a:solidFill>
-                <a:latin typeface="Arial" panose="020B0604020202020204" pitchFamily="34" charset="0"/>
-                <a:ea typeface="+mn-ea"/>
-                <a:cs typeface="+mn-cs"/>
-              </a:defRPr>
-            </a:lvl7pPr>
-            <a:lvl8pPr marL="3200400" algn="l" defTabSz="914400" rtl="0" eaLnBrk="1" latinLnBrk="0" hangingPunct="1">
-              <a:defRPr kern="1200">
-                <a:solidFill>
-                  <a:schemeClr val="tx1"/>
-                </a:solidFill>
-                <a:latin typeface="Arial" panose="020B0604020202020204" pitchFamily="34" charset="0"/>
-                <a:ea typeface="+mn-ea"/>
-                <a:cs typeface="+mn-cs"/>
-              </a:defRPr>
-            </a:lvl8pPr>
-            <a:lvl9pPr marL="3657600" algn="l" defTabSz="914400" rtl="0" eaLnBrk="1" latinLnBrk="0" hangingPunct="1">
-              <a:defRPr kern="1200">
-                <a:solidFill>
-                  <a:schemeClr val="tx1"/>
-                </a:solidFill>
-                <a:latin typeface="Arial" panose="020B0604020202020204" pitchFamily="34" charset="0"/>
-                <a:ea typeface="+mn-ea"/>
-                <a:cs typeface="+mn-cs"/>
-              </a:defRPr>
-            </a:lvl9pPr>
-          </a:lstStyle>
-          <a:p>
-            <a:pPr eaLnBrk="1" hangingPunct="1">
-              <a:defRPr/>
-            </a:pPr>
-            <a:r>
-              <a:rPr lang="en-US" altLang="zh-TW"/>
-              <a:t>Department of Computer Science and Engineering</a:t>
-            </a:r>
-            <a:endParaRPr lang="en-US" altLang="zh-TW">
-              <a:ea typeface="新細明體" charset="-120"/>
-            </a:endParaRPr>
-          </a:p>
-        </p:txBody>
-      </p:sp>
       <p:sp>
         <p:nvSpPr>
           <p:cNvPr id="3076" name="Slide Number Placeholder 5">

</xml_diff>